<commit_message>
added degradation corrected responses for ISWAT AR
</commit_message>
<xml_diff>
--- a/AIA_response_functions.pptx
+++ b/AIA_response_functions.pptx
@@ -3520,8 +3520,8 @@
         </p:nvSpPr>
         <p:spPr>
           <a:xfrm>
-            <a:off x="911299" y="4928448"/>
-            <a:ext cx="10369402" cy="883383"/>
+            <a:off x="646894" y="4772985"/>
+            <a:ext cx="8519140" cy="1928798"/>
           </a:xfrm>
           <a:prstGeom prst="rect">
             <a:avLst/>
@@ -3542,38 +3542,133 @@
               <a:buChar char="•"/>
             </a:pPr>
             <a:r>
+              <a:rPr lang="en-US" u="sng" dirty="0">
+                <a:solidFill>
+                  <a:srgbClr val="00B050"/>
+                </a:solidFill>
+              </a:rPr>
+              <a:t>Also compare chianti responses with SSW calculated response: </a:t>
+            </a:r>
+            <a:r>
+              <a:rPr lang="en-US" dirty="0">
+                <a:solidFill>
+                  <a:srgbClr val="00B050"/>
+                </a:solidFill>
+              </a:rPr>
+              <a:t>	</a:t>
+            </a:r>
+            <a:r>
+              <a:rPr lang="en-US" sz="1500" dirty="0" err="1"/>
+              <a:t>tresp</a:t>
+            </a:r>
+            <a:r>
+              <a:rPr lang="en-US" sz="1500" dirty="0"/>
+              <a:t>=</a:t>
+            </a:r>
+            <a:r>
+              <a:rPr lang="en-US" sz="1500" dirty="0" err="1"/>
+              <a:t>aia_get_response</a:t>
+            </a:r>
+            <a:r>
+              <a:rPr lang="en-US" sz="1500" dirty="0"/>
+              <a:t>(/temperature,/dn, </a:t>
+            </a:r>
+            <a:r>
+              <a:rPr lang="en-US" sz="1500" dirty="0" err="1"/>
+              <a:t>timedepend_date</a:t>
+            </a:r>
+            <a:r>
+              <a:rPr lang="en-US" sz="1500" dirty="0"/>
+              <a:t>=‘1-May-2010’,/area):</a:t>
+            </a:r>
+          </a:p>
+          <a:p>
+            <a:pPr marL="628650" lvl="1" indent="-171450">
+              <a:lnSpc>
+                <a:spcPct val="150000"/>
+              </a:lnSpc>
+              <a:buFont typeface="Arial" panose="020B0604020202020204" pitchFamily="34" charset="0"/>
+              <a:buChar char="•"/>
+            </a:pPr>
+            <a:r>
+              <a:rPr lang="en-US" sz="1500" dirty="0"/>
+              <a:t>In SSW calculation empirical correction (</a:t>
+            </a:r>
+            <a:r>
+              <a:rPr lang="en-US" sz="1500" dirty="0" err="1"/>
+              <a:t>chiantifix</a:t>
+            </a:r>
+            <a:r>
+              <a:rPr lang="en-US" sz="1500" dirty="0"/>
+              <a:t>) is not applied. </a:t>
+            </a:r>
+          </a:p>
+          <a:p>
+            <a:pPr marL="628650" lvl="1" indent="-171450">
+              <a:lnSpc>
+                <a:spcPct val="150000"/>
+              </a:lnSpc>
+              <a:buFont typeface="Arial" panose="020B0604020202020204" pitchFamily="34" charset="0"/>
+              <a:buChar char="•"/>
+            </a:pPr>
+            <a:r>
+              <a:rPr lang="en-US" sz="1500" dirty="0"/>
+              <a:t>SSW calculations are based on Chianti version-9</a:t>
+            </a:r>
+          </a:p>
+          <a:p>
+            <a:pPr marL="628650" lvl="1" indent="-171450">
+              <a:lnSpc>
+                <a:spcPct val="150000"/>
+              </a:lnSpc>
+              <a:buFont typeface="Arial" panose="020B0604020202020204" pitchFamily="34" charset="0"/>
+              <a:buChar char="•"/>
+            </a:pPr>
+            <a:r>
+              <a:rPr lang="en-US" sz="1500" dirty="0"/>
+              <a:t>SSW calculations used Feldman coronal abundances</a:t>
+            </a:r>
+          </a:p>
+        </p:txBody>
+      </p:sp>
+      <p:sp>
+        <p:nvSpPr>
+          <p:cNvPr id="2" name="TextBox 1">
+            <a:extLst>
+              <a:ext uri="{FF2B5EF4-FFF2-40B4-BE49-F238E27FC236}">
+                <a16:creationId xmlns:a16="http://schemas.microsoft.com/office/drawing/2014/main" id="{ABD7BCCC-7007-42C9-5509-95849E19AD6E}"/>
+              </a:ext>
+            </a:extLst>
+          </p:cNvPr>
+          <p:cNvSpPr txBox="1"/>
+          <p:nvPr/>
+        </p:nvSpPr>
+        <p:spPr>
+          <a:xfrm>
+            <a:off x="10146535" y="6055452"/>
+            <a:ext cx="1756828" cy="646331"/>
+          </a:xfrm>
+          <a:prstGeom prst="rect">
+            <a:avLst/>
+          </a:prstGeom>
+          <a:noFill/>
+        </p:spPr>
+        <p:txBody>
+          <a:bodyPr wrap="none" rtlCol="0">
+            <a:spAutoFit/>
+          </a:bodyPr>
+          <a:lstStyle/>
+          <a:p>
+            <a:r>
               <a:rPr lang="en-US" dirty="0"/>
-              <a:t>Also compare chianti responses with SSW calculated response: </a:t>
-            </a:r>
-            <a:r>
-              <a:rPr lang="en-US" dirty="0" err="1"/>
-              <a:t>tresp</a:t>
-            </a:r>
+              <a:t>Biswajit Mondal</a:t>
+            </a:r>
+          </a:p>
+          <a:p>
             <a:r>
               <a:rPr lang="en-US" dirty="0"/>
-              <a:t>=</a:t>
-            </a:r>
-            <a:r>
-              <a:rPr lang="en-US" dirty="0" err="1"/>
-              <a:t>aia_get_response</a:t>
-            </a:r>
-            <a:r>
-              <a:rPr lang="en-US" dirty="0"/>
-              <a:t>(/temperature,/dn, </a:t>
-            </a:r>
-            <a:r>
-              <a:rPr lang="en-US" dirty="0" err="1"/>
-              <a:t>timedepend_date</a:t>
-            </a:r>
-            <a:r>
-              <a:rPr lang="en-US" dirty="0"/>
-              <a:t>=‘</a:t>
-            </a:r>
-            <a:r>
-              <a:rPr lang="en-US"/>
-              <a:t>1-May-2010’,/area): </a:t>
-            </a:r>
-            <a:endParaRPr lang="en-US" dirty="0"/>
+              <a:t>Oct.15.2026</a:t>
+            </a:r>
           </a:p>
         </p:txBody>
       </p:sp>
@@ -4225,10 +4320,10 @@
       </p:sp>
       <p:sp>
         <p:nvSpPr>
-          <p:cNvPr id="10" name="TextBox 9">
-            <a:extLst>
-              <a:ext uri="{FF2B5EF4-FFF2-40B4-BE49-F238E27FC236}">
-                <a16:creationId xmlns:a16="http://schemas.microsoft.com/office/drawing/2014/main" id="{C9BD3680-8A84-145E-967A-AC67416A0CE6}"/>
+          <p:cNvPr id="3" name="TextBox 2">
+            <a:extLst>
+              <a:ext uri="{FF2B5EF4-FFF2-40B4-BE49-F238E27FC236}">
+                <a16:creationId xmlns:a16="http://schemas.microsoft.com/office/drawing/2014/main" id="{2B51519B-DA03-D430-C683-78276503646A}"/>
               </a:ext>
             </a:extLst>
           </p:cNvPr>
@@ -4237,123 +4332,8 @@
         </p:nvSpPr>
         <p:spPr>
           <a:xfrm>
-            <a:off x="371094" y="2718054"/>
-            <a:ext cx="3438906" cy="3207258"/>
-          </a:xfrm>
-          <a:prstGeom prst="rect">
-            <a:avLst/>
-          </a:prstGeom>
-        </p:spPr>
-        <p:txBody>
-          <a:bodyPr vert="horz" lIns="91440" tIns="45720" rIns="91440" bIns="45720" rtlCol="0">
-            <a:normAutofit/>
-          </a:bodyPr>
-          <a:lstStyle/>
-          <a:p>
-            <a:pPr indent="-228600">
-              <a:lnSpc>
-                <a:spcPct val="90000"/>
-              </a:lnSpc>
-              <a:spcAft>
-                <a:spcPts val="600"/>
-              </a:spcAft>
-              <a:buFont typeface="Arial" panose="020B0604020202020204" pitchFamily="34" charset="0"/>
-              <a:buChar char="•"/>
-            </a:pPr>
-            <a:r>
-              <a:rPr lang="en-US" sz="1700"/>
-              <a:t>Solid line: SSW calculated response, which used: </a:t>
-            </a:r>
-          </a:p>
-          <a:p>
-            <a:pPr lvl="1" indent="-228600">
-              <a:lnSpc>
-                <a:spcPct val="90000"/>
-              </a:lnSpc>
-              <a:spcAft>
-                <a:spcPts val="600"/>
-              </a:spcAft>
-              <a:buFont typeface="Arial" panose="020B0604020202020204" pitchFamily="34" charset="0"/>
-              <a:buChar char="•"/>
-            </a:pPr>
-            <a:r>
-              <a:rPr lang="en-US" sz="1700"/>
-              <a:t>Chianti v-9</a:t>
-            </a:r>
-          </a:p>
-          <a:p>
-            <a:pPr lvl="1" indent="-228600">
-              <a:lnSpc>
-                <a:spcPct val="90000"/>
-              </a:lnSpc>
-              <a:spcAft>
-                <a:spcPts val="600"/>
-              </a:spcAft>
-              <a:buFont typeface="Arial" panose="020B0604020202020204" pitchFamily="34" charset="0"/>
-              <a:buChar char="•"/>
-            </a:pPr>
-            <a:r>
-              <a:rPr lang="en-US" sz="1700"/>
-              <a:t>Feldman coronal abundance</a:t>
-            </a:r>
-          </a:p>
-          <a:p>
-            <a:pPr marL="285750" indent="-228600">
-              <a:lnSpc>
-                <a:spcPct val="90000"/>
-              </a:lnSpc>
-              <a:spcAft>
-                <a:spcPts val="600"/>
-              </a:spcAft>
-              <a:buFont typeface="Arial" panose="020B0604020202020204" pitchFamily="34" charset="0"/>
-              <a:buChar char="•"/>
-            </a:pPr>
-            <a:endParaRPr lang="en-US" sz="1700" dirty="0"/>
-          </a:p>
-          <a:p>
-            <a:pPr marL="285750" indent="-228600">
-              <a:lnSpc>
-                <a:spcPct val="90000"/>
-              </a:lnSpc>
-              <a:spcAft>
-                <a:spcPts val="600"/>
-              </a:spcAft>
-              <a:buFont typeface="Arial" panose="020B0604020202020204" pitchFamily="34" charset="0"/>
-              <a:buChar char="•"/>
-            </a:pPr>
-            <a:endParaRPr lang="en-US" sz="1700" dirty="0"/>
-          </a:p>
-          <a:p>
-            <a:pPr marL="285750" indent="-228600">
-              <a:lnSpc>
-                <a:spcPct val="90000"/>
-              </a:lnSpc>
-              <a:spcAft>
-                <a:spcPts val="600"/>
-              </a:spcAft>
-              <a:buFont typeface="Arial" panose="020B0604020202020204" pitchFamily="34" charset="0"/>
-              <a:buChar char="•"/>
-            </a:pPr>
-            <a:endParaRPr lang="en-US" sz="1700" dirty="0"/>
-          </a:p>
-        </p:txBody>
-      </p:sp>
-      <p:sp>
-        <p:nvSpPr>
-          <p:cNvPr id="3" name="TextBox 2">
-            <a:extLst>
-              <a:ext uri="{FF2B5EF4-FFF2-40B4-BE49-F238E27FC236}">
-                <a16:creationId xmlns:a16="http://schemas.microsoft.com/office/drawing/2014/main" id="{2B51519B-DA03-D430-C683-78276503646A}"/>
-              </a:ext>
-            </a:extLst>
-          </p:cNvPr>
-          <p:cNvSpPr txBox="1"/>
-          <p:nvPr/>
-        </p:nvSpPr>
-        <p:spPr>
-          <a:xfrm>
-            <a:off x="368808" y="5910094"/>
-            <a:ext cx="6950814" cy="646331"/>
+            <a:off x="301255" y="3571180"/>
+            <a:ext cx="4788538" cy="1200329"/>
           </a:xfrm>
           <a:prstGeom prst="rect">
             <a:avLst/>
@@ -4361,7 +4341,7 @@
           <a:noFill/>
         </p:spPr>
         <p:txBody>
-          <a:bodyPr wrap="none" rtlCol="0">
+          <a:bodyPr wrap="square" rtlCol="0">
             <a:spAutoFit/>
           </a:bodyPr>
           <a:lstStyle/>
@@ -4382,13 +4362,8 @@
           <a:p>
             <a:r>
               <a:rPr lang="en-US" b="1" dirty="0"/>
-              <a:t>- Change of atomic data in new Chianti </a:t>
-            </a:r>
-            <a:r>
-              <a:rPr lang="en-US" b="1"/>
-              <a:t>version ?</a:t>
-            </a:r>
-            <a:endParaRPr lang="en-US" b="1" dirty="0"/>
+              <a:t>- Change of atomic data in new Chianti version ?</a:t>
+            </a:r>
           </a:p>
         </p:txBody>
       </p:sp>
@@ -4422,6 +4397,96 @@
           </a:prstGeom>
         </p:spPr>
       </p:pic>
+      <p:sp>
+        <p:nvSpPr>
+          <p:cNvPr id="2" name="TextBox 1">
+            <a:extLst>
+              <a:ext uri="{FF2B5EF4-FFF2-40B4-BE49-F238E27FC236}">
+                <a16:creationId xmlns:a16="http://schemas.microsoft.com/office/drawing/2014/main" id="{1BFA53C7-A9A3-009F-4E71-CFF3A09F673B}"/>
+              </a:ext>
+            </a:extLst>
+          </p:cNvPr>
+          <p:cNvSpPr txBox="1"/>
+          <p:nvPr/>
+        </p:nvSpPr>
+        <p:spPr>
+          <a:xfrm>
+            <a:off x="5879528" y="2883307"/>
+            <a:ext cx="3870400" cy="646331"/>
+          </a:xfrm>
+          <a:prstGeom prst="rect">
+            <a:avLst/>
+          </a:prstGeom>
+        </p:spPr>
+        <p:txBody>
+          <a:bodyPr vert="horz" lIns="91440" tIns="45720" rIns="91440" bIns="45720" rtlCol="0">
+            <a:normAutofit/>
+          </a:bodyPr>
+          <a:lstStyle/>
+          <a:p>
+            <a:pPr indent="-228600">
+              <a:lnSpc>
+                <a:spcPct val="90000"/>
+              </a:lnSpc>
+              <a:spcAft>
+                <a:spcPts val="600"/>
+              </a:spcAft>
+              <a:buFont typeface="Arial" panose="020B0604020202020204" pitchFamily="34" charset="0"/>
+              <a:buChar char="•"/>
+            </a:pPr>
+            <a:r>
+              <a:rPr lang="en-US" sz="1700" dirty="0">
+                <a:solidFill>
+                  <a:schemeClr val="tx2">
+                    <a:lumMod val="75000"/>
+                    <a:lumOff val="25000"/>
+                  </a:schemeClr>
+                </a:solidFill>
+              </a:rPr>
+              <a:t>Solid line: SSW calculated response</a:t>
+            </a:r>
+          </a:p>
+          <a:p>
+            <a:pPr marL="285750" indent="-228600">
+              <a:lnSpc>
+                <a:spcPct val="90000"/>
+              </a:lnSpc>
+              <a:spcAft>
+                <a:spcPts val="600"/>
+              </a:spcAft>
+              <a:buFont typeface="Arial" panose="020B0604020202020204" pitchFamily="34" charset="0"/>
+              <a:buChar char="•"/>
+            </a:pPr>
+            <a:endParaRPr lang="en-US" sz="1700" dirty="0"/>
+          </a:p>
+          <a:p>
+            <a:pPr marL="285750" indent="-228600">
+              <a:lnSpc>
+                <a:spcPct val="90000"/>
+              </a:lnSpc>
+              <a:spcAft>
+                <a:spcPts val="600"/>
+              </a:spcAft>
+              <a:buFont typeface="Arial" panose="020B0604020202020204" pitchFamily="34" charset="0"/>
+              <a:buChar char="•"/>
+            </a:pPr>
+            <a:endParaRPr lang="en-US" sz="1700" dirty="0"/>
+          </a:p>
+          <a:p>
+            <a:pPr marL="285750" indent="-228600">
+              <a:lnSpc>
+                <a:spcPct val="90000"/>
+              </a:lnSpc>
+              <a:spcAft>
+                <a:spcPts val="600"/>
+              </a:spcAft>
+              <a:buFont typeface="Arial" panose="020B0604020202020204" pitchFamily="34" charset="0"/>
+              <a:buChar char="•"/>
+            </a:pPr>
+            <a:endParaRPr lang="en-US" sz="1700" dirty="0"/>
+          </a:p>
+        </p:txBody>
+      </p:sp>
     </p:spTree>
     <p:extLst>
       <p:ext uri="{BB962C8B-B14F-4D97-AF65-F5344CB8AC3E}">
@@ -5074,156 +5139,6 @@
           </a:p>
         </p:txBody>
       </p:sp>
-      <p:sp>
-        <p:nvSpPr>
-          <p:cNvPr id="9" name="TextBox 8">
-            <a:extLst>
-              <a:ext uri="{FF2B5EF4-FFF2-40B4-BE49-F238E27FC236}">
-                <a16:creationId xmlns:a16="http://schemas.microsoft.com/office/drawing/2014/main" id="{2B23E4F0-C209-91D6-6962-C5F8CD249E48}"/>
-              </a:ext>
-            </a:extLst>
-          </p:cNvPr>
-          <p:cNvSpPr txBox="1"/>
-          <p:nvPr/>
-        </p:nvSpPr>
-        <p:spPr>
-          <a:xfrm>
-            <a:off x="371094" y="2718054"/>
-            <a:ext cx="3438906" cy="3207258"/>
-          </a:xfrm>
-          <a:prstGeom prst="rect">
-            <a:avLst/>
-          </a:prstGeom>
-        </p:spPr>
-        <p:txBody>
-          <a:bodyPr vert="horz" lIns="91440" tIns="45720" rIns="91440" bIns="45720" rtlCol="0">
-            <a:normAutofit/>
-          </a:bodyPr>
-          <a:lstStyle/>
-          <a:p>
-            <a:pPr indent="-228600">
-              <a:lnSpc>
-                <a:spcPct val="90000"/>
-              </a:lnSpc>
-              <a:spcAft>
-                <a:spcPts val="600"/>
-              </a:spcAft>
-              <a:buFont typeface="Arial" panose="020B0604020202020204" pitchFamily="34" charset="0"/>
-              <a:buChar char="•"/>
-            </a:pPr>
-            <a:r>
-              <a:rPr lang="en-US" sz="1700" dirty="0"/>
-              <a:t>Solid line: SSW calculated response, which used: </a:t>
-            </a:r>
-          </a:p>
-          <a:p>
-            <a:pPr lvl="1" indent="-228600">
-              <a:lnSpc>
-                <a:spcPct val="90000"/>
-              </a:lnSpc>
-              <a:spcAft>
-                <a:spcPts val="600"/>
-              </a:spcAft>
-              <a:buFont typeface="Arial" panose="020B0604020202020204" pitchFamily="34" charset="0"/>
-              <a:buChar char="•"/>
-            </a:pPr>
-            <a:r>
-              <a:rPr lang="en-US" sz="1700" dirty="0"/>
-              <a:t>Chianti v-9</a:t>
-            </a:r>
-          </a:p>
-          <a:p>
-            <a:pPr lvl="1" indent="-228600">
-              <a:lnSpc>
-                <a:spcPct val="90000"/>
-              </a:lnSpc>
-              <a:spcAft>
-                <a:spcPts val="600"/>
-              </a:spcAft>
-              <a:buFont typeface="Arial" panose="020B0604020202020204" pitchFamily="34" charset="0"/>
-              <a:buChar char="•"/>
-            </a:pPr>
-            <a:r>
-              <a:rPr lang="en-US" sz="1700" dirty="0"/>
-              <a:t>Feldman coronal abundance</a:t>
-            </a:r>
-          </a:p>
-          <a:p>
-            <a:pPr marL="285750" indent="-228600">
-              <a:lnSpc>
-                <a:spcPct val="90000"/>
-              </a:lnSpc>
-              <a:spcAft>
-                <a:spcPts val="600"/>
-              </a:spcAft>
-              <a:buFont typeface="Arial" panose="020B0604020202020204" pitchFamily="34" charset="0"/>
-              <a:buChar char="•"/>
-            </a:pPr>
-            <a:endParaRPr lang="en-US" sz="1700" dirty="0"/>
-          </a:p>
-          <a:p>
-            <a:pPr marL="285750" indent="-228600">
-              <a:lnSpc>
-                <a:spcPct val="90000"/>
-              </a:lnSpc>
-              <a:spcAft>
-                <a:spcPts val="600"/>
-              </a:spcAft>
-              <a:buFont typeface="Arial" panose="020B0604020202020204" pitchFamily="34" charset="0"/>
-              <a:buChar char="•"/>
-            </a:pPr>
-            <a:endParaRPr lang="en-US" sz="1700" dirty="0"/>
-          </a:p>
-          <a:p>
-            <a:pPr marL="285750" indent="-228600">
-              <a:lnSpc>
-                <a:spcPct val="90000"/>
-              </a:lnSpc>
-              <a:spcAft>
-                <a:spcPts val="600"/>
-              </a:spcAft>
-              <a:buFont typeface="Arial" panose="020B0604020202020204" pitchFamily="34" charset="0"/>
-              <a:buChar char="•"/>
-            </a:pPr>
-            <a:endParaRPr lang="en-US" sz="1700" dirty="0"/>
-          </a:p>
-        </p:txBody>
-      </p:sp>
-      <p:sp>
-        <p:nvSpPr>
-          <p:cNvPr id="3" name="TextBox 2">
-            <a:extLst>
-              <a:ext uri="{FF2B5EF4-FFF2-40B4-BE49-F238E27FC236}">
-                <a16:creationId xmlns:a16="http://schemas.microsoft.com/office/drawing/2014/main" id="{DB50A09B-A667-2C93-CAF7-7AFF4DA57E60}"/>
-              </a:ext>
-            </a:extLst>
-          </p:cNvPr>
-          <p:cNvSpPr txBox="1"/>
-          <p:nvPr/>
-        </p:nvSpPr>
-        <p:spPr>
-          <a:xfrm>
-            <a:off x="368808" y="5910094"/>
-            <a:ext cx="2549609" cy="369332"/>
-          </a:xfrm>
-          <a:prstGeom prst="rect">
-            <a:avLst/>
-          </a:prstGeom>
-          <a:noFill/>
-        </p:spPr>
-        <p:txBody>
-          <a:bodyPr wrap="none" rtlCol="0">
-            <a:spAutoFit/>
-          </a:bodyPr>
-          <a:lstStyle/>
-          <a:p>
-            <a:r>
-              <a:rPr lang="en-US" dirty="0"/>
-              <a:t>Overall good agreement</a:t>
-            </a:r>
-          </a:p>
-        </p:txBody>
-      </p:sp>
       <p:pic>
         <p:nvPicPr>
           <p:cNvPr id="4" name="Picture 3">
@@ -5254,6 +5169,131 @@
           </a:prstGeom>
         </p:spPr>
       </p:pic>
+      <p:sp>
+        <p:nvSpPr>
+          <p:cNvPr id="2" name="TextBox 1">
+            <a:extLst>
+              <a:ext uri="{FF2B5EF4-FFF2-40B4-BE49-F238E27FC236}">
+                <a16:creationId xmlns:a16="http://schemas.microsoft.com/office/drawing/2014/main" id="{02929EF2-85C0-223A-15EF-07F785A62228}"/>
+              </a:ext>
+            </a:extLst>
+          </p:cNvPr>
+          <p:cNvSpPr txBox="1"/>
+          <p:nvPr/>
+        </p:nvSpPr>
+        <p:spPr>
+          <a:xfrm>
+            <a:off x="6704665" y="4800242"/>
+            <a:ext cx="3870400" cy="646331"/>
+          </a:xfrm>
+          <a:prstGeom prst="rect">
+            <a:avLst/>
+          </a:prstGeom>
+        </p:spPr>
+        <p:txBody>
+          <a:bodyPr vert="horz" lIns="91440" tIns="45720" rIns="91440" bIns="45720" rtlCol="0">
+            <a:normAutofit/>
+          </a:bodyPr>
+          <a:lstStyle/>
+          <a:p>
+            <a:pPr indent="-228600">
+              <a:lnSpc>
+                <a:spcPct val="90000"/>
+              </a:lnSpc>
+              <a:spcAft>
+                <a:spcPts val="600"/>
+              </a:spcAft>
+              <a:buFont typeface="Arial" panose="020B0604020202020204" pitchFamily="34" charset="0"/>
+              <a:buChar char="•"/>
+            </a:pPr>
+            <a:r>
+              <a:rPr lang="en-US" sz="1700" dirty="0">
+                <a:solidFill>
+                  <a:schemeClr val="tx2">
+                    <a:lumMod val="75000"/>
+                    <a:lumOff val="25000"/>
+                  </a:schemeClr>
+                </a:solidFill>
+              </a:rPr>
+              <a:t>Solid line: SSW calculated response</a:t>
+            </a:r>
+          </a:p>
+          <a:p>
+            <a:pPr marL="285750" indent="-228600">
+              <a:lnSpc>
+                <a:spcPct val="90000"/>
+              </a:lnSpc>
+              <a:spcAft>
+                <a:spcPts val="600"/>
+              </a:spcAft>
+              <a:buFont typeface="Arial" panose="020B0604020202020204" pitchFamily="34" charset="0"/>
+              <a:buChar char="•"/>
+            </a:pPr>
+            <a:endParaRPr lang="en-US" sz="1700" dirty="0"/>
+          </a:p>
+          <a:p>
+            <a:pPr marL="285750" indent="-228600">
+              <a:lnSpc>
+                <a:spcPct val="90000"/>
+              </a:lnSpc>
+              <a:spcAft>
+                <a:spcPts val="600"/>
+              </a:spcAft>
+              <a:buFont typeface="Arial" panose="020B0604020202020204" pitchFamily="34" charset="0"/>
+              <a:buChar char="•"/>
+            </a:pPr>
+            <a:endParaRPr lang="en-US" sz="1700" dirty="0"/>
+          </a:p>
+          <a:p>
+            <a:pPr marL="285750" indent="-228600">
+              <a:lnSpc>
+                <a:spcPct val="90000"/>
+              </a:lnSpc>
+              <a:spcAft>
+                <a:spcPts val="600"/>
+              </a:spcAft>
+              <a:buFont typeface="Arial" panose="020B0604020202020204" pitchFamily="34" charset="0"/>
+              <a:buChar char="•"/>
+            </a:pPr>
+            <a:endParaRPr lang="en-US" sz="1700" dirty="0"/>
+          </a:p>
+        </p:txBody>
+      </p:sp>
+      <p:sp>
+        <p:nvSpPr>
+          <p:cNvPr id="6" name="TextBox 5">
+            <a:extLst>
+              <a:ext uri="{FF2B5EF4-FFF2-40B4-BE49-F238E27FC236}">
+                <a16:creationId xmlns:a16="http://schemas.microsoft.com/office/drawing/2014/main" id="{65DF8FFB-6BE4-3BDA-CD73-816AB79C13A9}"/>
+              </a:ext>
+            </a:extLst>
+          </p:cNvPr>
+          <p:cNvSpPr txBox="1"/>
+          <p:nvPr/>
+        </p:nvSpPr>
+        <p:spPr>
+          <a:xfrm>
+            <a:off x="863008" y="3002711"/>
+            <a:ext cx="2549609" cy="369332"/>
+          </a:xfrm>
+          <a:prstGeom prst="rect">
+            <a:avLst/>
+          </a:prstGeom>
+          <a:noFill/>
+        </p:spPr>
+        <p:txBody>
+          <a:bodyPr wrap="none" rtlCol="0">
+            <a:spAutoFit/>
+          </a:bodyPr>
+          <a:lstStyle/>
+          <a:p>
+            <a:r>
+              <a:rPr lang="en-US" dirty="0"/>
+              <a:t>Overall good agreement</a:t>
+            </a:r>
+          </a:p>
+        </p:txBody>
+      </p:sp>
     </p:spTree>
     <p:extLst>
       <p:ext uri="{BB962C8B-B14F-4D97-AF65-F5344CB8AC3E}">
@@ -5906,156 +5946,6 @@
           </a:p>
         </p:txBody>
       </p:sp>
-      <p:sp>
-        <p:nvSpPr>
-          <p:cNvPr id="10" name="TextBox 9">
-            <a:extLst>
-              <a:ext uri="{FF2B5EF4-FFF2-40B4-BE49-F238E27FC236}">
-                <a16:creationId xmlns:a16="http://schemas.microsoft.com/office/drawing/2014/main" id="{E42F9D1F-BD16-1F55-6259-6F884A88209A}"/>
-              </a:ext>
-            </a:extLst>
-          </p:cNvPr>
-          <p:cNvSpPr txBox="1"/>
-          <p:nvPr/>
-        </p:nvSpPr>
-        <p:spPr>
-          <a:xfrm>
-            <a:off x="371094" y="2718054"/>
-            <a:ext cx="3438906" cy="3207258"/>
-          </a:xfrm>
-          <a:prstGeom prst="rect">
-            <a:avLst/>
-          </a:prstGeom>
-        </p:spPr>
-        <p:txBody>
-          <a:bodyPr vert="horz" lIns="91440" tIns="45720" rIns="91440" bIns="45720" rtlCol="0">
-            <a:normAutofit/>
-          </a:bodyPr>
-          <a:lstStyle/>
-          <a:p>
-            <a:pPr indent="-228600">
-              <a:lnSpc>
-                <a:spcPct val="90000"/>
-              </a:lnSpc>
-              <a:spcAft>
-                <a:spcPts val="600"/>
-              </a:spcAft>
-              <a:buFont typeface="Arial" panose="020B0604020202020204" pitchFamily="34" charset="0"/>
-              <a:buChar char="•"/>
-            </a:pPr>
-            <a:r>
-              <a:rPr lang="en-US" sz="1700"/>
-              <a:t>Solid line: SSW calculated response, which used: </a:t>
-            </a:r>
-          </a:p>
-          <a:p>
-            <a:pPr lvl="1" indent="-228600">
-              <a:lnSpc>
-                <a:spcPct val="90000"/>
-              </a:lnSpc>
-              <a:spcAft>
-                <a:spcPts val="600"/>
-              </a:spcAft>
-              <a:buFont typeface="Arial" panose="020B0604020202020204" pitchFamily="34" charset="0"/>
-              <a:buChar char="•"/>
-            </a:pPr>
-            <a:r>
-              <a:rPr lang="en-US" sz="1700"/>
-              <a:t>Chianti v-9</a:t>
-            </a:r>
-          </a:p>
-          <a:p>
-            <a:pPr lvl="1" indent="-228600">
-              <a:lnSpc>
-                <a:spcPct val="90000"/>
-              </a:lnSpc>
-              <a:spcAft>
-                <a:spcPts val="600"/>
-              </a:spcAft>
-              <a:buFont typeface="Arial" panose="020B0604020202020204" pitchFamily="34" charset="0"/>
-              <a:buChar char="•"/>
-            </a:pPr>
-            <a:r>
-              <a:rPr lang="en-US" sz="1700"/>
-              <a:t>Feldman coronal abundance</a:t>
-            </a:r>
-          </a:p>
-          <a:p>
-            <a:pPr marL="285750" indent="-228600">
-              <a:lnSpc>
-                <a:spcPct val="90000"/>
-              </a:lnSpc>
-              <a:spcAft>
-                <a:spcPts val="600"/>
-              </a:spcAft>
-              <a:buFont typeface="Arial" panose="020B0604020202020204" pitchFamily="34" charset="0"/>
-              <a:buChar char="•"/>
-            </a:pPr>
-            <a:endParaRPr lang="en-US" sz="1700" dirty="0"/>
-          </a:p>
-          <a:p>
-            <a:pPr marL="285750" indent="-228600">
-              <a:lnSpc>
-                <a:spcPct val="90000"/>
-              </a:lnSpc>
-              <a:spcAft>
-                <a:spcPts val="600"/>
-              </a:spcAft>
-              <a:buFont typeface="Arial" panose="020B0604020202020204" pitchFamily="34" charset="0"/>
-              <a:buChar char="•"/>
-            </a:pPr>
-            <a:endParaRPr lang="en-US" sz="1700" dirty="0"/>
-          </a:p>
-          <a:p>
-            <a:pPr marL="285750" indent="-228600">
-              <a:lnSpc>
-                <a:spcPct val="90000"/>
-              </a:lnSpc>
-              <a:spcAft>
-                <a:spcPts val="600"/>
-              </a:spcAft>
-              <a:buFont typeface="Arial" panose="020B0604020202020204" pitchFamily="34" charset="0"/>
-              <a:buChar char="•"/>
-            </a:pPr>
-            <a:endParaRPr lang="en-US" sz="1700" dirty="0"/>
-          </a:p>
-        </p:txBody>
-      </p:sp>
-      <p:sp>
-        <p:nvSpPr>
-          <p:cNvPr id="3" name="TextBox 2">
-            <a:extLst>
-              <a:ext uri="{FF2B5EF4-FFF2-40B4-BE49-F238E27FC236}">
-                <a16:creationId xmlns:a16="http://schemas.microsoft.com/office/drawing/2014/main" id="{35816EF0-CADF-3D00-F844-2A2C47756716}"/>
-              </a:ext>
-            </a:extLst>
-          </p:cNvPr>
-          <p:cNvSpPr txBox="1"/>
-          <p:nvPr/>
-        </p:nvSpPr>
-        <p:spPr>
-          <a:xfrm>
-            <a:off x="368808" y="5910094"/>
-            <a:ext cx="2549609" cy="369332"/>
-          </a:xfrm>
-          <a:prstGeom prst="rect">
-            <a:avLst/>
-          </a:prstGeom>
-          <a:noFill/>
-        </p:spPr>
-        <p:txBody>
-          <a:bodyPr wrap="none" rtlCol="0">
-            <a:spAutoFit/>
-          </a:bodyPr>
-          <a:lstStyle/>
-          <a:p>
-            <a:r>
-              <a:rPr lang="en-US" dirty="0"/>
-              <a:t>Overall good agreement</a:t>
-            </a:r>
-          </a:p>
-        </p:txBody>
-      </p:sp>
       <p:pic>
         <p:nvPicPr>
           <p:cNvPr id="4" name="Picture 3">
@@ -6086,6 +5976,131 @@
           </a:prstGeom>
         </p:spPr>
       </p:pic>
+      <p:sp>
+        <p:nvSpPr>
+          <p:cNvPr id="2" name="TextBox 1">
+            <a:extLst>
+              <a:ext uri="{FF2B5EF4-FFF2-40B4-BE49-F238E27FC236}">
+                <a16:creationId xmlns:a16="http://schemas.microsoft.com/office/drawing/2014/main" id="{F36CAE0B-02AE-1B05-3212-E40368404286}"/>
+              </a:ext>
+            </a:extLst>
+          </p:cNvPr>
+          <p:cNvSpPr txBox="1"/>
+          <p:nvPr/>
+        </p:nvSpPr>
+        <p:spPr>
+          <a:xfrm>
+            <a:off x="6096000" y="4734141"/>
+            <a:ext cx="3870400" cy="646331"/>
+          </a:xfrm>
+          <a:prstGeom prst="rect">
+            <a:avLst/>
+          </a:prstGeom>
+        </p:spPr>
+        <p:txBody>
+          <a:bodyPr vert="horz" lIns="91440" tIns="45720" rIns="91440" bIns="45720" rtlCol="0">
+            <a:normAutofit/>
+          </a:bodyPr>
+          <a:lstStyle/>
+          <a:p>
+            <a:pPr indent="-228600">
+              <a:lnSpc>
+                <a:spcPct val="90000"/>
+              </a:lnSpc>
+              <a:spcAft>
+                <a:spcPts val="600"/>
+              </a:spcAft>
+              <a:buFont typeface="Arial" panose="020B0604020202020204" pitchFamily="34" charset="0"/>
+              <a:buChar char="•"/>
+            </a:pPr>
+            <a:r>
+              <a:rPr lang="en-US" sz="1700" dirty="0">
+                <a:solidFill>
+                  <a:schemeClr val="tx2">
+                    <a:lumMod val="75000"/>
+                    <a:lumOff val="25000"/>
+                  </a:schemeClr>
+                </a:solidFill>
+              </a:rPr>
+              <a:t>Solid line: SSW calculated response</a:t>
+            </a:r>
+          </a:p>
+          <a:p>
+            <a:pPr marL="285750" indent="-228600">
+              <a:lnSpc>
+                <a:spcPct val="90000"/>
+              </a:lnSpc>
+              <a:spcAft>
+                <a:spcPts val="600"/>
+              </a:spcAft>
+              <a:buFont typeface="Arial" panose="020B0604020202020204" pitchFamily="34" charset="0"/>
+              <a:buChar char="•"/>
+            </a:pPr>
+            <a:endParaRPr lang="en-US" sz="1700" dirty="0"/>
+          </a:p>
+          <a:p>
+            <a:pPr marL="285750" indent="-228600">
+              <a:lnSpc>
+                <a:spcPct val="90000"/>
+              </a:lnSpc>
+              <a:spcAft>
+                <a:spcPts val="600"/>
+              </a:spcAft>
+              <a:buFont typeface="Arial" panose="020B0604020202020204" pitchFamily="34" charset="0"/>
+              <a:buChar char="•"/>
+            </a:pPr>
+            <a:endParaRPr lang="en-US" sz="1700" dirty="0"/>
+          </a:p>
+          <a:p>
+            <a:pPr marL="285750" indent="-228600">
+              <a:lnSpc>
+                <a:spcPct val="90000"/>
+              </a:lnSpc>
+              <a:spcAft>
+                <a:spcPts val="600"/>
+              </a:spcAft>
+              <a:buFont typeface="Arial" panose="020B0604020202020204" pitchFamily="34" charset="0"/>
+              <a:buChar char="•"/>
+            </a:pPr>
+            <a:endParaRPr lang="en-US" sz="1700" dirty="0"/>
+          </a:p>
+        </p:txBody>
+      </p:sp>
+      <p:sp>
+        <p:nvSpPr>
+          <p:cNvPr id="6" name="TextBox 5">
+            <a:extLst>
+              <a:ext uri="{FF2B5EF4-FFF2-40B4-BE49-F238E27FC236}">
+                <a16:creationId xmlns:a16="http://schemas.microsoft.com/office/drawing/2014/main" id="{8F03B2BD-DD9F-58D8-88E5-16282CFA0D40}"/>
+              </a:ext>
+            </a:extLst>
+          </p:cNvPr>
+          <p:cNvSpPr txBox="1"/>
+          <p:nvPr/>
+        </p:nvSpPr>
+        <p:spPr>
+          <a:xfrm>
+            <a:off x="863008" y="3002711"/>
+            <a:ext cx="2549609" cy="369332"/>
+          </a:xfrm>
+          <a:prstGeom prst="rect">
+            <a:avLst/>
+          </a:prstGeom>
+          <a:noFill/>
+        </p:spPr>
+        <p:txBody>
+          <a:bodyPr wrap="none" rtlCol="0">
+            <a:spAutoFit/>
+          </a:bodyPr>
+          <a:lstStyle/>
+          <a:p>
+            <a:r>
+              <a:rPr lang="en-US" dirty="0"/>
+              <a:t>Overall good agreement</a:t>
+            </a:r>
+          </a:p>
+        </p:txBody>
+      </p:sp>
     </p:spTree>
     <p:extLst>
       <p:ext uri="{BB962C8B-B14F-4D97-AF65-F5344CB8AC3E}">
@@ -6738,156 +6753,6 @@
           </a:p>
         </p:txBody>
       </p:sp>
-      <p:sp>
-        <p:nvSpPr>
-          <p:cNvPr id="8" name="TextBox 7">
-            <a:extLst>
-              <a:ext uri="{FF2B5EF4-FFF2-40B4-BE49-F238E27FC236}">
-                <a16:creationId xmlns:a16="http://schemas.microsoft.com/office/drawing/2014/main" id="{A3427B7B-54FF-073A-F1D6-C4FF4BCACE8F}"/>
-              </a:ext>
-            </a:extLst>
-          </p:cNvPr>
-          <p:cNvSpPr txBox="1"/>
-          <p:nvPr/>
-        </p:nvSpPr>
-        <p:spPr>
-          <a:xfrm>
-            <a:off x="371094" y="2718054"/>
-            <a:ext cx="3438906" cy="3207258"/>
-          </a:xfrm>
-          <a:prstGeom prst="rect">
-            <a:avLst/>
-          </a:prstGeom>
-        </p:spPr>
-        <p:txBody>
-          <a:bodyPr vert="horz" lIns="91440" tIns="45720" rIns="91440" bIns="45720" rtlCol="0">
-            <a:normAutofit/>
-          </a:bodyPr>
-          <a:lstStyle/>
-          <a:p>
-            <a:pPr indent="-228600">
-              <a:lnSpc>
-                <a:spcPct val="90000"/>
-              </a:lnSpc>
-              <a:spcAft>
-                <a:spcPts val="600"/>
-              </a:spcAft>
-              <a:buFont typeface="Arial" panose="020B0604020202020204" pitchFamily="34" charset="0"/>
-              <a:buChar char="•"/>
-            </a:pPr>
-            <a:r>
-              <a:rPr lang="en-US" sz="1700"/>
-              <a:t>Solid line: SSW calculated response, which used: </a:t>
-            </a:r>
-          </a:p>
-          <a:p>
-            <a:pPr lvl="1" indent="-228600">
-              <a:lnSpc>
-                <a:spcPct val="90000"/>
-              </a:lnSpc>
-              <a:spcAft>
-                <a:spcPts val="600"/>
-              </a:spcAft>
-              <a:buFont typeface="Arial" panose="020B0604020202020204" pitchFamily="34" charset="0"/>
-              <a:buChar char="•"/>
-            </a:pPr>
-            <a:r>
-              <a:rPr lang="en-US" sz="1700"/>
-              <a:t>Chianti v-9</a:t>
-            </a:r>
-          </a:p>
-          <a:p>
-            <a:pPr lvl="1" indent="-228600">
-              <a:lnSpc>
-                <a:spcPct val="90000"/>
-              </a:lnSpc>
-              <a:spcAft>
-                <a:spcPts val="600"/>
-              </a:spcAft>
-              <a:buFont typeface="Arial" panose="020B0604020202020204" pitchFamily="34" charset="0"/>
-              <a:buChar char="•"/>
-            </a:pPr>
-            <a:r>
-              <a:rPr lang="en-US" sz="1700"/>
-              <a:t>Feldman coronal abundance</a:t>
-            </a:r>
-          </a:p>
-          <a:p>
-            <a:pPr marL="285750" indent="-228600">
-              <a:lnSpc>
-                <a:spcPct val="90000"/>
-              </a:lnSpc>
-              <a:spcAft>
-                <a:spcPts val="600"/>
-              </a:spcAft>
-              <a:buFont typeface="Arial" panose="020B0604020202020204" pitchFamily="34" charset="0"/>
-              <a:buChar char="•"/>
-            </a:pPr>
-            <a:endParaRPr lang="en-US" sz="1700" dirty="0"/>
-          </a:p>
-          <a:p>
-            <a:pPr marL="285750" indent="-228600">
-              <a:lnSpc>
-                <a:spcPct val="90000"/>
-              </a:lnSpc>
-              <a:spcAft>
-                <a:spcPts val="600"/>
-              </a:spcAft>
-              <a:buFont typeface="Arial" panose="020B0604020202020204" pitchFamily="34" charset="0"/>
-              <a:buChar char="•"/>
-            </a:pPr>
-            <a:endParaRPr lang="en-US" sz="1700" dirty="0"/>
-          </a:p>
-          <a:p>
-            <a:pPr marL="285750" indent="-228600">
-              <a:lnSpc>
-                <a:spcPct val="90000"/>
-              </a:lnSpc>
-              <a:spcAft>
-                <a:spcPts val="600"/>
-              </a:spcAft>
-              <a:buFont typeface="Arial" panose="020B0604020202020204" pitchFamily="34" charset="0"/>
-              <a:buChar char="•"/>
-            </a:pPr>
-            <a:endParaRPr lang="en-US" sz="1700" dirty="0"/>
-          </a:p>
-        </p:txBody>
-      </p:sp>
-      <p:sp>
-        <p:nvSpPr>
-          <p:cNvPr id="3" name="TextBox 2">
-            <a:extLst>
-              <a:ext uri="{FF2B5EF4-FFF2-40B4-BE49-F238E27FC236}">
-                <a16:creationId xmlns:a16="http://schemas.microsoft.com/office/drawing/2014/main" id="{5F125B02-0508-C44D-3C4E-93D0F9E25769}"/>
-              </a:ext>
-            </a:extLst>
-          </p:cNvPr>
-          <p:cNvSpPr txBox="1"/>
-          <p:nvPr/>
-        </p:nvSpPr>
-        <p:spPr>
-          <a:xfrm>
-            <a:off x="368808" y="5910094"/>
-            <a:ext cx="2549609" cy="369332"/>
-          </a:xfrm>
-          <a:prstGeom prst="rect">
-            <a:avLst/>
-          </a:prstGeom>
-          <a:noFill/>
-        </p:spPr>
-        <p:txBody>
-          <a:bodyPr wrap="none" rtlCol="0">
-            <a:spAutoFit/>
-          </a:bodyPr>
-          <a:lstStyle/>
-          <a:p>
-            <a:r>
-              <a:rPr lang="en-US" dirty="0"/>
-              <a:t>Overall good agreement</a:t>
-            </a:r>
-          </a:p>
-        </p:txBody>
-      </p:sp>
       <p:pic>
         <p:nvPicPr>
           <p:cNvPr id="4" name="Picture 3">
@@ -6918,6 +6783,131 @@
           </a:prstGeom>
         </p:spPr>
       </p:pic>
+      <p:sp>
+        <p:nvSpPr>
+          <p:cNvPr id="2" name="TextBox 1">
+            <a:extLst>
+              <a:ext uri="{FF2B5EF4-FFF2-40B4-BE49-F238E27FC236}">
+                <a16:creationId xmlns:a16="http://schemas.microsoft.com/office/drawing/2014/main" id="{D370F134-E9C6-C1BC-4904-CDF046C985F7}"/>
+              </a:ext>
+            </a:extLst>
+          </p:cNvPr>
+          <p:cNvSpPr txBox="1"/>
+          <p:nvPr/>
+        </p:nvSpPr>
+        <p:spPr>
+          <a:xfrm>
+            <a:off x="6188454" y="1285861"/>
+            <a:ext cx="3870400" cy="646331"/>
+          </a:xfrm>
+          <a:prstGeom prst="rect">
+            <a:avLst/>
+          </a:prstGeom>
+        </p:spPr>
+        <p:txBody>
+          <a:bodyPr vert="horz" lIns="91440" tIns="45720" rIns="91440" bIns="45720" rtlCol="0">
+            <a:normAutofit/>
+          </a:bodyPr>
+          <a:lstStyle/>
+          <a:p>
+            <a:pPr indent="-228600">
+              <a:lnSpc>
+                <a:spcPct val="90000"/>
+              </a:lnSpc>
+              <a:spcAft>
+                <a:spcPts val="600"/>
+              </a:spcAft>
+              <a:buFont typeface="Arial" panose="020B0604020202020204" pitchFamily="34" charset="0"/>
+              <a:buChar char="•"/>
+            </a:pPr>
+            <a:r>
+              <a:rPr lang="en-US" sz="1700" dirty="0">
+                <a:solidFill>
+                  <a:schemeClr val="tx2">
+                    <a:lumMod val="75000"/>
+                    <a:lumOff val="25000"/>
+                  </a:schemeClr>
+                </a:solidFill>
+              </a:rPr>
+              <a:t>Solid line: SSW calculated response</a:t>
+            </a:r>
+          </a:p>
+          <a:p>
+            <a:pPr marL="285750" indent="-228600">
+              <a:lnSpc>
+                <a:spcPct val="90000"/>
+              </a:lnSpc>
+              <a:spcAft>
+                <a:spcPts val="600"/>
+              </a:spcAft>
+              <a:buFont typeface="Arial" panose="020B0604020202020204" pitchFamily="34" charset="0"/>
+              <a:buChar char="•"/>
+            </a:pPr>
+            <a:endParaRPr lang="en-US" sz="1700" dirty="0"/>
+          </a:p>
+          <a:p>
+            <a:pPr marL="285750" indent="-228600">
+              <a:lnSpc>
+                <a:spcPct val="90000"/>
+              </a:lnSpc>
+              <a:spcAft>
+                <a:spcPts val="600"/>
+              </a:spcAft>
+              <a:buFont typeface="Arial" panose="020B0604020202020204" pitchFamily="34" charset="0"/>
+              <a:buChar char="•"/>
+            </a:pPr>
+            <a:endParaRPr lang="en-US" sz="1700" dirty="0"/>
+          </a:p>
+          <a:p>
+            <a:pPr marL="285750" indent="-228600">
+              <a:lnSpc>
+                <a:spcPct val="90000"/>
+              </a:lnSpc>
+              <a:spcAft>
+                <a:spcPts val="600"/>
+              </a:spcAft>
+              <a:buFont typeface="Arial" panose="020B0604020202020204" pitchFamily="34" charset="0"/>
+              <a:buChar char="•"/>
+            </a:pPr>
+            <a:endParaRPr lang="en-US" sz="1700" dirty="0"/>
+          </a:p>
+        </p:txBody>
+      </p:sp>
+      <p:sp>
+        <p:nvSpPr>
+          <p:cNvPr id="6" name="TextBox 5">
+            <a:extLst>
+              <a:ext uri="{FF2B5EF4-FFF2-40B4-BE49-F238E27FC236}">
+                <a16:creationId xmlns:a16="http://schemas.microsoft.com/office/drawing/2014/main" id="{7C11D801-39EB-F64C-9499-F1C767259B52}"/>
+              </a:ext>
+            </a:extLst>
+          </p:cNvPr>
+          <p:cNvSpPr txBox="1"/>
+          <p:nvPr/>
+        </p:nvSpPr>
+        <p:spPr>
+          <a:xfrm>
+            <a:off x="863008" y="3002711"/>
+            <a:ext cx="2549609" cy="369332"/>
+          </a:xfrm>
+          <a:prstGeom prst="rect">
+            <a:avLst/>
+          </a:prstGeom>
+          <a:noFill/>
+        </p:spPr>
+        <p:txBody>
+          <a:bodyPr wrap="none" rtlCol="0">
+            <a:spAutoFit/>
+          </a:bodyPr>
+          <a:lstStyle/>
+          <a:p>
+            <a:r>
+              <a:rPr lang="en-US" dirty="0"/>
+              <a:t>Overall good agreement</a:t>
+            </a:r>
+          </a:p>
+        </p:txBody>
+      </p:sp>
     </p:spTree>
     <p:extLst>
       <p:ext uri="{BB962C8B-B14F-4D97-AF65-F5344CB8AC3E}">
@@ -7570,156 +7560,6 @@
           </a:p>
         </p:txBody>
       </p:sp>
-      <p:sp>
-        <p:nvSpPr>
-          <p:cNvPr id="11" name="TextBox 10">
-            <a:extLst>
-              <a:ext uri="{FF2B5EF4-FFF2-40B4-BE49-F238E27FC236}">
-                <a16:creationId xmlns:a16="http://schemas.microsoft.com/office/drawing/2014/main" id="{2BA5D557-FA23-7D34-7A47-D69858C64695}"/>
-              </a:ext>
-            </a:extLst>
-          </p:cNvPr>
-          <p:cNvSpPr txBox="1"/>
-          <p:nvPr/>
-        </p:nvSpPr>
-        <p:spPr>
-          <a:xfrm>
-            <a:off x="371094" y="2718054"/>
-            <a:ext cx="3438906" cy="3207258"/>
-          </a:xfrm>
-          <a:prstGeom prst="rect">
-            <a:avLst/>
-          </a:prstGeom>
-        </p:spPr>
-        <p:txBody>
-          <a:bodyPr vert="horz" lIns="91440" tIns="45720" rIns="91440" bIns="45720" rtlCol="0">
-            <a:normAutofit/>
-          </a:bodyPr>
-          <a:lstStyle/>
-          <a:p>
-            <a:pPr indent="-228600">
-              <a:lnSpc>
-                <a:spcPct val="90000"/>
-              </a:lnSpc>
-              <a:spcAft>
-                <a:spcPts val="600"/>
-              </a:spcAft>
-              <a:buFont typeface="Arial" panose="020B0604020202020204" pitchFamily="34" charset="0"/>
-              <a:buChar char="•"/>
-            </a:pPr>
-            <a:r>
-              <a:rPr lang="en-US" sz="1700" dirty="0"/>
-              <a:t>Solid line: SSW calculated response, which used: </a:t>
-            </a:r>
-          </a:p>
-          <a:p>
-            <a:pPr lvl="1" indent="-228600">
-              <a:lnSpc>
-                <a:spcPct val="90000"/>
-              </a:lnSpc>
-              <a:spcAft>
-                <a:spcPts val="600"/>
-              </a:spcAft>
-              <a:buFont typeface="Arial" panose="020B0604020202020204" pitchFamily="34" charset="0"/>
-              <a:buChar char="•"/>
-            </a:pPr>
-            <a:r>
-              <a:rPr lang="en-US" sz="1700" dirty="0"/>
-              <a:t>Chianti v-9</a:t>
-            </a:r>
-          </a:p>
-          <a:p>
-            <a:pPr lvl="1" indent="-228600">
-              <a:lnSpc>
-                <a:spcPct val="90000"/>
-              </a:lnSpc>
-              <a:spcAft>
-                <a:spcPts val="600"/>
-              </a:spcAft>
-              <a:buFont typeface="Arial" panose="020B0604020202020204" pitchFamily="34" charset="0"/>
-              <a:buChar char="•"/>
-            </a:pPr>
-            <a:r>
-              <a:rPr lang="en-US" sz="1700" dirty="0"/>
-              <a:t>Feldman coronal abundance</a:t>
-            </a:r>
-          </a:p>
-          <a:p>
-            <a:pPr marL="285750" indent="-228600">
-              <a:lnSpc>
-                <a:spcPct val="90000"/>
-              </a:lnSpc>
-              <a:spcAft>
-                <a:spcPts val="600"/>
-              </a:spcAft>
-              <a:buFont typeface="Arial" panose="020B0604020202020204" pitchFamily="34" charset="0"/>
-              <a:buChar char="•"/>
-            </a:pPr>
-            <a:endParaRPr lang="en-US" sz="1700" dirty="0"/>
-          </a:p>
-          <a:p>
-            <a:pPr marL="285750" indent="-228600">
-              <a:lnSpc>
-                <a:spcPct val="90000"/>
-              </a:lnSpc>
-              <a:spcAft>
-                <a:spcPts val="600"/>
-              </a:spcAft>
-              <a:buFont typeface="Arial" panose="020B0604020202020204" pitchFamily="34" charset="0"/>
-              <a:buChar char="•"/>
-            </a:pPr>
-            <a:endParaRPr lang="en-US" sz="1700" dirty="0"/>
-          </a:p>
-          <a:p>
-            <a:pPr marL="285750" indent="-228600">
-              <a:lnSpc>
-                <a:spcPct val="90000"/>
-              </a:lnSpc>
-              <a:spcAft>
-                <a:spcPts val="600"/>
-              </a:spcAft>
-              <a:buFont typeface="Arial" panose="020B0604020202020204" pitchFamily="34" charset="0"/>
-              <a:buChar char="•"/>
-            </a:pPr>
-            <a:endParaRPr lang="en-US" sz="1700" dirty="0"/>
-          </a:p>
-        </p:txBody>
-      </p:sp>
-      <p:sp>
-        <p:nvSpPr>
-          <p:cNvPr id="3" name="TextBox 2">
-            <a:extLst>
-              <a:ext uri="{FF2B5EF4-FFF2-40B4-BE49-F238E27FC236}">
-                <a16:creationId xmlns:a16="http://schemas.microsoft.com/office/drawing/2014/main" id="{190B403E-4D79-BC6E-57B2-4D32411A06AB}"/>
-              </a:ext>
-            </a:extLst>
-          </p:cNvPr>
-          <p:cNvSpPr txBox="1"/>
-          <p:nvPr/>
-        </p:nvSpPr>
-        <p:spPr>
-          <a:xfrm>
-            <a:off x="368808" y="5910094"/>
-            <a:ext cx="2549609" cy="369332"/>
-          </a:xfrm>
-          <a:prstGeom prst="rect">
-            <a:avLst/>
-          </a:prstGeom>
-          <a:noFill/>
-        </p:spPr>
-        <p:txBody>
-          <a:bodyPr wrap="none" rtlCol="0">
-            <a:spAutoFit/>
-          </a:bodyPr>
-          <a:lstStyle/>
-          <a:p>
-            <a:r>
-              <a:rPr lang="en-US" dirty="0"/>
-              <a:t>Overall good agreement</a:t>
-            </a:r>
-          </a:p>
-        </p:txBody>
-      </p:sp>
       <p:pic>
         <p:nvPicPr>
           <p:cNvPr id="4" name="Picture 3">
@@ -7750,6 +7590,131 @@
           </a:prstGeom>
         </p:spPr>
       </p:pic>
+      <p:sp>
+        <p:nvSpPr>
+          <p:cNvPr id="2" name="TextBox 1">
+            <a:extLst>
+              <a:ext uri="{FF2B5EF4-FFF2-40B4-BE49-F238E27FC236}">
+                <a16:creationId xmlns:a16="http://schemas.microsoft.com/office/drawing/2014/main" id="{CDD569DD-CD93-8B61-6A19-C3F61CB12F54}"/>
+              </a:ext>
+            </a:extLst>
+          </p:cNvPr>
+          <p:cNvSpPr txBox="1"/>
+          <p:nvPr/>
+        </p:nvSpPr>
+        <p:spPr>
+          <a:xfrm>
+            <a:off x="5967663" y="4612955"/>
+            <a:ext cx="3870400" cy="646331"/>
+          </a:xfrm>
+          <a:prstGeom prst="rect">
+            <a:avLst/>
+          </a:prstGeom>
+        </p:spPr>
+        <p:txBody>
+          <a:bodyPr vert="horz" lIns="91440" tIns="45720" rIns="91440" bIns="45720" rtlCol="0">
+            <a:normAutofit/>
+          </a:bodyPr>
+          <a:lstStyle/>
+          <a:p>
+            <a:pPr indent="-228600">
+              <a:lnSpc>
+                <a:spcPct val="90000"/>
+              </a:lnSpc>
+              <a:spcAft>
+                <a:spcPts val="600"/>
+              </a:spcAft>
+              <a:buFont typeface="Arial" panose="020B0604020202020204" pitchFamily="34" charset="0"/>
+              <a:buChar char="•"/>
+            </a:pPr>
+            <a:r>
+              <a:rPr lang="en-US" sz="1700" dirty="0">
+                <a:solidFill>
+                  <a:schemeClr val="tx2">
+                    <a:lumMod val="75000"/>
+                    <a:lumOff val="25000"/>
+                  </a:schemeClr>
+                </a:solidFill>
+              </a:rPr>
+              <a:t>Solid line: SSW calculated response</a:t>
+            </a:r>
+          </a:p>
+          <a:p>
+            <a:pPr marL="285750" indent="-228600">
+              <a:lnSpc>
+                <a:spcPct val="90000"/>
+              </a:lnSpc>
+              <a:spcAft>
+                <a:spcPts val="600"/>
+              </a:spcAft>
+              <a:buFont typeface="Arial" panose="020B0604020202020204" pitchFamily="34" charset="0"/>
+              <a:buChar char="•"/>
+            </a:pPr>
+            <a:endParaRPr lang="en-US" sz="1700" dirty="0"/>
+          </a:p>
+          <a:p>
+            <a:pPr marL="285750" indent="-228600">
+              <a:lnSpc>
+                <a:spcPct val="90000"/>
+              </a:lnSpc>
+              <a:spcAft>
+                <a:spcPts val="600"/>
+              </a:spcAft>
+              <a:buFont typeface="Arial" panose="020B0604020202020204" pitchFamily="34" charset="0"/>
+              <a:buChar char="•"/>
+            </a:pPr>
+            <a:endParaRPr lang="en-US" sz="1700" dirty="0"/>
+          </a:p>
+          <a:p>
+            <a:pPr marL="285750" indent="-228600">
+              <a:lnSpc>
+                <a:spcPct val="90000"/>
+              </a:lnSpc>
+              <a:spcAft>
+                <a:spcPts val="600"/>
+              </a:spcAft>
+              <a:buFont typeface="Arial" panose="020B0604020202020204" pitchFamily="34" charset="0"/>
+              <a:buChar char="•"/>
+            </a:pPr>
+            <a:endParaRPr lang="en-US" sz="1700" dirty="0"/>
+          </a:p>
+        </p:txBody>
+      </p:sp>
+      <p:sp>
+        <p:nvSpPr>
+          <p:cNvPr id="7" name="TextBox 6">
+            <a:extLst>
+              <a:ext uri="{FF2B5EF4-FFF2-40B4-BE49-F238E27FC236}">
+                <a16:creationId xmlns:a16="http://schemas.microsoft.com/office/drawing/2014/main" id="{67FFA76A-6981-722A-6CE6-990B8D9DC0D8}"/>
+              </a:ext>
+            </a:extLst>
+          </p:cNvPr>
+          <p:cNvSpPr txBox="1"/>
+          <p:nvPr/>
+        </p:nvSpPr>
+        <p:spPr>
+          <a:xfrm>
+            <a:off x="863008" y="3002711"/>
+            <a:ext cx="2549609" cy="369332"/>
+          </a:xfrm>
+          <a:prstGeom prst="rect">
+            <a:avLst/>
+          </a:prstGeom>
+          <a:noFill/>
+        </p:spPr>
+        <p:txBody>
+          <a:bodyPr wrap="none" rtlCol="0">
+            <a:spAutoFit/>
+          </a:bodyPr>
+          <a:lstStyle/>
+          <a:p>
+            <a:r>
+              <a:rPr lang="en-US" dirty="0"/>
+              <a:t>Overall good agreement</a:t>
+            </a:r>
+          </a:p>
+        </p:txBody>
+      </p:sp>
     </p:spTree>
     <p:extLst>
       <p:ext uri="{BB962C8B-B14F-4D97-AF65-F5344CB8AC3E}">
@@ -8402,162 +8367,6 @@
           </a:p>
         </p:txBody>
       </p:sp>
-      <p:sp>
-        <p:nvSpPr>
-          <p:cNvPr id="8" name="TextBox 7">
-            <a:extLst>
-              <a:ext uri="{FF2B5EF4-FFF2-40B4-BE49-F238E27FC236}">
-                <a16:creationId xmlns:a16="http://schemas.microsoft.com/office/drawing/2014/main" id="{33078D77-53F5-5060-0835-721F0633FA09}"/>
-              </a:ext>
-            </a:extLst>
-          </p:cNvPr>
-          <p:cNvSpPr txBox="1"/>
-          <p:nvPr/>
-        </p:nvSpPr>
-        <p:spPr>
-          <a:xfrm>
-            <a:off x="371094" y="2718054"/>
-            <a:ext cx="3438906" cy="3207258"/>
-          </a:xfrm>
-          <a:prstGeom prst="rect">
-            <a:avLst/>
-          </a:prstGeom>
-        </p:spPr>
-        <p:txBody>
-          <a:bodyPr vert="horz" lIns="91440" tIns="45720" rIns="91440" bIns="45720" rtlCol="0">
-            <a:normAutofit/>
-          </a:bodyPr>
-          <a:lstStyle/>
-          <a:p>
-            <a:pPr indent="-228600">
-              <a:lnSpc>
-                <a:spcPct val="90000"/>
-              </a:lnSpc>
-              <a:spcAft>
-                <a:spcPts val="600"/>
-              </a:spcAft>
-              <a:buFont typeface="Arial" panose="020B0604020202020204" pitchFamily="34" charset="0"/>
-              <a:buChar char="•"/>
-            </a:pPr>
-            <a:r>
-              <a:rPr lang="en-US" sz="1700" dirty="0"/>
-              <a:t>Solid line: SSW calculated response, which used: </a:t>
-            </a:r>
-          </a:p>
-          <a:p>
-            <a:pPr lvl="1" indent="-228600">
-              <a:lnSpc>
-                <a:spcPct val="90000"/>
-              </a:lnSpc>
-              <a:spcAft>
-                <a:spcPts val="600"/>
-              </a:spcAft>
-              <a:buFont typeface="Arial" panose="020B0604020202020204" pitchFamily="34" charset="0"/>
-              <a:buChar char="•"/>
-            </a:pPr>
-            <a:r>
-              <a:rPr lang="en-US" sz="1700" dirty="0"/>
-              <a:t>Chianti v-9</a:t>
-            </a:r>
-          </a:p>
-          <a:p>
-            <a:pPr lvl="1" indent="-228600">
-              <a:lnSpc>
-                <a:spcPct val="90000"/>
-              </a:lnSpc>
-              <a:spcAft>
-                <a:spcPts val="600"/>
-              </a:spcAft>
-              <a:buFont typeface="Arial" panose="020B0604020202020204" pitchFamily="34" charset="0"/>
-              <a:buChar char="•"/>
-            </a:pPr>
-            <a:r>
-              <a:rPr lang="en-US" sz="1700" dirty="0"/>
-              <a:t>Feldman coronal abundance</a:t>
-            </a:r>
-          </a:p>
-          <a:p>
-            <a:pPr marL="285750" indent="-228600">
-              <a:lnSpc>
-                <a:spcPct val="90000"/>
-              </a:lnSpc>
-              <a:spcAft>
-                <a:spcPts val="600"/>
-              </a:spcAft>
-              <a:buFont typeface="Arial" panose="020B0604020202020204" pitchFamily="34" charset="0"/>
-              <a:buChar char="•"/>
-            </a:pPr>
-            <a:endParaRPr lang="en-US" sz="1700" dirty="0"/>
-          </a:p>
-          <a:p>
-            <a:pPr marL="285750" indent="-228600">
-              <a:lnSpc>
-                <a:spcPct val="90000"/>
-              </a:lnSpc>
-              <a:spcAft>
-                <a:spcPts val="600"/>
-              </a:spcAft>
-              <a:buFont typeface="Arial" panose="020B0604020202020204" pitchFamily="34" charset="0"/>
-              <a:buChar char="•"/>
-            </a:pPr>
-            <a:endParaRPr lang="en-US" sz="1700" dirty="0"/>
-          </a:p>
-          <a:p>
-            <a:pPr marL="285750" indent="-228600">
-              <a:lnSpc>
-                <a:spcPct val="90000"/>
-              </a:lnSpc>
-              <a:spcAft>
-                <a:spcPts val="600"/>
-              </a:spcAft>
-              <a:buFont typeface="Arial" panose="020B0604020202020204" pitchFamily="34" charset="0"/>
-              <a:buChar char="•"/>
-            </a:pPr>
-            <a:endParaRPr lang="en-US" sz="1700" dirty="0"/>
-          </a:p>
-        </p:txBody>
-      </p:sp>
-      <p:sp>
-        <p:nvSpPr>
-          <p:cNvPr id="3" name="TextBox 2">
-            <a:extLst>
-              <a:ext uri="{FF2B5EF4-FFF2-40B4-BE49-F238E27FC236}">
-                <a16:creationId xmlns:a16="http://schemas.microsoft.com/office/drawing/2014/main" id="{E71042DC-A2FC-CFDB-91E5-E99B1F62622E}"/>
-              </a:ext>
-            </a:extLst>
-          </p:cNvPr>
-          <p:cNvSpPr txBox="1"/>
-          <p:nvPr/>
-        </p:nvSpPr>
-        <p:spPr>
-          <a:xfrm>
-            <a:off x="439628" y="5696712"/>
-            <a:ext cx="5127237" cy="646331"/>
-          </a:xfrm>
-          <a:prstGeom prst="rect">
-            <a:avLst/>
-          </a:prstGeom>
-          <a:noFill/>
-        </p:spPr>
-        <p:txBody>
-          <a:bodyPr wrap="none" rtlCol="0">
-            <a:spAutoFit/>
-          </a:bodyPr>
-          <a:lstStyle/>
-          <a:p>
-            <a:r>
-              <a:rPr lang="en-US" dirty="0"/>
-              <a:t>This passband show significant deviation.</a:t>
-            </a:r>
-          </a:p>
-          <a:p>
-            <a:r>
-              <a:rPr lang="en-US" b="1" dirty="0"/>
-              <a:t>- Change of atomic data in new Chianti version?</a:t>
-            </a:r>
-          </a:p>
-        </p:txBody>
-      </p:sp>
       <p:pic>
         <p:nvPicPr>
           <p:cNvPr id="4" name="Picture 3">
@@ -8588,6 +8397,141 @@
           </a:prstGeom>
         </p:spPr>
       </p:pic>
+      <p:sp>
+        <p:nvSpPr>
+          <p:cNvPr id="2" name="TextBox 1">
+            <a:extLst>
+              <a:ext uri="{FF2B5EF4-FFF2-40B4-BE49-F238E27FC236}">
+                <a16:creationId xmlns:a16="http://schemas.microsoft.com/office/drawing/2014/main" id="{E3748179-5DB8-14B9-17CD-BCD0A3AE066F}"/>
+              </a:ext>
+            </a:extLst>
+          </p:cNvPr>
+          <p:cNvSpPr txBox="1"/>
+          <p:nvPr/>
+        </p:nvSpPr>
+        <p:spPr>
+          <a:xfrm>
+            <a:off x="5835460" y="5036252"/>
+            <a:ext cx="3870400" cy="646331"/>
+          </a:xfrm>
+          <a:prstGeom prst="rect">
+            <a:avLst/>
+          </a:prstGeom>
+        </p:spPr>
+        <p:txBody>
+          <a:bodyPr vert="horz" lIns="91440" tIns="45720" rIns="91440" bIns="45720" rtlCol="0">
+            <a:normAutofit/>
+          </a:bodyPr>
+          <a:lstStyle/>
+          <a:p>
+            <a:pPr indent="-228600">
+              <a:lnSpc>
+                <a:spcPct val="90000"/>
+              </a:lnSpc>
+              <a:spcAft>
+                <a:spcPts val="600"/>
+              </a:spcAft>
+              <a:buFont typeface="Arial" panose="020B0604020202020204" pitchFamily="34" charset="0"/>
+              <a:buChar char="•"/>
+            </a:pPr>
+            <a:r>
+              <a:rPr lang="en-US" sz="1700" dirty="0">
+                <a:solidFill>
+                  <a:schemeClr val="tx2">
+                    <a:lumMod val="75000"/>
+                    <a:lumOff val="25000"/>
+                  </a:schemeClr>
+                </a:solidFill>
+              </a:rPr>
+              <a:t>Solid line: SSW calculated response</a:t>
+            </a:r>
+          </a:p>
+          <a:p>
+            <a:pPr marL="285750" indent="-228600">
+              <a:lnSpc>
+                <a:spcPct val="90000"/>
+              </a:lnSpc>
+              <a:spcAft>
+                <a:spcPts val="600"/>
+              </a:spcAft>
+              <a:buFont typeface="Arial" panose="020B0604020202020204" pitchFamily="34" charset="0"/>
+              <a:buChar char="•"/>
+            </a:pPr>
+            <a:endParaRPr lang="en-US" sz="1700" dirty="0"/>
+          </a:p>
+          <a:p>
+            <a:pPr marL="285750" indent="-228600">
+              <a:lnSpc>
+                <a:spcPct val="90000"/>
+              </a:lnSpc>
+              <a:spcAft>
+                <a:spcPts val="600"/>
+              </a:spcAft>
+              <a:buFont typeface="Arial" panose="020B0604020202020204" pitchFamily="34" charset="0"/>
+              <a:buChar char="•"/>
+            </a:pPr>
+            <a:endParaRPr lang="en-US" sz="1700" dirty="0"/>
+          </a:p>
+          <a:p>
+            <a:pPr marL="285750" indent="-228600">
+              <a:lnSpc>
+                <a:spcPct val="90000"/>
+              </a:lnSpc>
+              <a:spcAft>
+                <a:spcPts val="600"/>
+              </a:spcAft>
+              <a:buFont typeface="Arial" panose="020B0604020202020204" pitchFamily="34" charset="0"/>
+              <a:buChar char="•"/>
+            </a:pPr>
+            <a:endParaRPr lang="en-US" sz="1700" dirty="0"/>
+          </a:p>
+        </p:txBody>
+      </p:sp>
+      <p:sp>
+        <p:nvSpPr>
+          <p:cNvPr id="3" name="TextBox 2">
+            <a:extLst>
+              <a:ext uri="{FF2B5EF4-FFF2-40B4-BE49-F238E27FC236}">
+                <a16:creationId xmlns:a16="http://schemas.microsoft.com/office/drawing/2014/main" id="{E71042DC-A2FC-CFDB-91E5-E99B1F62622E}"/>
+              </a:ext>
+            </a:extLst>
+          </p:cNvPr>
+          <p:cNvSpPr txBox="1"/>
+          <p:nvPr/>
+        </p:nvSpPr>
+        <p:spPr>
+          <a:xfrm>
+            <a:off x="0" y="2874824"/>
+            <a:ext cx="4770304" cy="1200329"/>
+          </a:xfrm>
+          <a:prstGeom prst="rect">
+            <a:avLst/>
+          </a:prstGeom>
+          <a:noFill/>
+        </p:spPr>
+        <p:txBody>
+          <a:bodyPr wrap="square" rtlCol="0">
+            <a:spAutoFit/>
+          </a:bodyPr>
+          <a:lstStyle/>
+          <a:p>
+            <a:r>
+              <a:rPr lang="en-US" dirty="0"/>
+              <a:t>This passband show significant deviation.</a:t>
+            </a:r>
+          </a:p>
+          <a:p>
+            <a:pPr marL="285750" indent="-285750">
+              <a:buFontTx/>
+              <a:buChar char="-"/>
+            </a:pPr>
+            <a:r>
+              <a:rPr lang="en-US" b="1" dirty="0"/>
+              <a:t>SSW uses some empirical factor to compensate optically thick He-II emission?</a:t>
+            </a:r>
+          </a:p>
+        </p:txBody>
+      </p:sp>
     </p:spTree>
     <p:extLst>
       <p:ext uri="{BB962C8B-B14F-4D97-AF65-F5344CB8AC3E}">
@@ -9242,10 +9186,10 @@
       </p:sp>
       <p:sp>
         <p:nvSpPr>
-          <p:cNvPr id="9" name="TextBox 8">
-            <a:extLst>
-              <a:ext uri="{FF2B5EF4-FFF2-40B4-BE49-F238E27FC236}">
-                <a16:creationId xmlns:a16="http://schemas.microsoft.com/office/drawing/2014/main" id="{523D487D-2A8D-A85F-7DEC-FF127A83D5F6}"/>
+          <p:cNvPr id="3" name="TextBox 2">
+            <a:extLst>
+              <a:ext uri="{FF2B5EF4-FFF2-40B4-BE49-F238E27FC236}">
+                <a16:creationId xmlns:a16="http://schemas.microsoft.com/office/drawing/2014/main" id="{01E05E28-6183-8B23-4E92-E8D4A9456DDA}"/>
               </a:ext>
             </a:extLst>
           </p:cNvPr>
@@ -9254,122 +9198,7 @@
         </p:nvSpPr>
         <p:spPr>
           <a:xfrm>
-            <a:off x="371094" y="2718054"/>
-            <a:ext cx="3438906" cy="3207258"/>
-          </a:xfrm>
-          <a:prstGeom prst="rect">
-            <a:avLst/>
-          </a:prstGeom>
-        </p:spPr>
-        <p:txBody>
-          <a:bodyPr vert="horz" lIns="91440" tIns="45720" rIns="91440" bIns="45720" rtlCol="0">
-            <a:normAutofit/>
-          </a:bodyPr>
-          <a:lstStyle/>
-          <a:p>
-            <a:pPr indent="-228600">
-              <a:lnSpc>
-                <a:spcPct val="90000"/>
-              </a:lnSpc>
-              <a:spcAft>
-                <a:spcPts val="600"/>
-              </a:spcAft>
-              <a:buFont typeface="Arial" panose="020B0604020202020204" pitchFamily="34" charset="0"/>
-              <a:buChar char="•"/>
-            </a:pPr>
-            <a:r>
-              <a:rPr lang="en-US" sz="1700" dirty="0"/>
-              <a:t>Solid line: SSW calculated response, which used: </a:t>
-            </a:r>
-          </a:p>
-          <a:p>
-            <a:pPr lvl="1" indent="-228600">
-              <a:lnSpc>
-                <a:spcPct val="90000"/>
-              </a:lnSpc>
-              <a:spcAft>
-                <a:spcPts val="600"/>
-              </a:spcAft>
-              <a:buFont typeface="Arial" panose="020B0604020202020204" pitchFamily="34" charset="0"/>
-              <a:buChar char="•"/>
-            </a:pPr>
-            <a:r>
-              <a:rPr lang="en-US" sz="1700" dirty="0"/>
-              <a:t>Chianti v-9</a:t>
-            </a:r>
-          </a:p>
-          <a:p>
-            <a:pPr lvl="1" indent="-228600">
-              <a:lnSpc>
-                <a:spcPct val="90000"/>
-              </a:lnSpc>
-              <a:spcAft>
-                <a:spcPts val="600"/>
-              </a:spcAft>
-              <a:buFont typeface="Arial" panose="020B0604020202020204" pitchFamily="34" charset="0"/>
-              <a:buChar char="•"/>
-            </a:pPr>
-            <a:r>
-              <a:rPr lang="en-US" sz="1700" dirty="0"/>
-              <a:t>Feldman coronal abundance</a:t>
-            </a:r>
-          </a:p>
-          <a:p>
-            <a:pPr marL="285750" indent="-228600">
-              <a:lnSpc>
-                <a:spcPct val="90000"/>
-              </a:lnSpc>
-              <a:spcAft>
-                <a:spcPts val="600"/>
-              </a:spcAft>
-              <a:buFont typeface="Arial" panose="020B0604020202020204" pitchFamily="34" charset="0"/>
-              <a:buChar char="•"/>
-            </a:pPr>
-            <a:endParaRPr lang="en-US" sz="1700" dirty="0"/>
-          </a:p>
-          <a:p>
-            <a:pPr marL="285750" indent="-228600">
-              <a:lnSpc>
-                <a:spcPct val="90000"/>
-              </a:lnSpc>
-              <a:spcAft>
-                <a:spcPts val="600"/>
-              </a:spcAft>
-              <a:buFont typeface="Arial" panose="020B0604020202020204" pitchFamily="34" charset="0"/>
-              <a:buChar char="•"/>
-            </a:pPr>
-            <a:endParaRPr lang="en-US" sz="1700" dirty="0"/>
-          </a:p>
-          <a:p>
-            <a:pPr marL="285750" indent="-228600">
-              <a:lnSpc>
-                <a:spcPct val="90000"/>
-              </a:lnSpc>
-              <a:spcAft>
-                <a:spcPts val="600"/>
-              </a:spcAft>
-              <a:buFont typeface="Arial" panose="020B0604020202020204" pitchFamily="34" charset="0"/>
-              <a:buChar char="•"/>
-            </a:pPr>
-            <a:endParaRPr lang="en-US" sz="1700" dirty="0"/>
-          </a:p>
-        </p:txBody>
-      </p:sp>
-      <p:sp>
-        <p:nvSpPr>
-          <p:cNvPr id="3" name="TextBox 2">
-            <a:extLst>
-              <a:ext uri="{FF2B5EF4-FFF2-40B4-BE49-F238E27FC236}">
-                <a16:creationId xmlns:a16="http://schemas.microsoft.com/office/drawing/2014/main" id="{01E05E28-6183-8B23-4E92-E8D4A9456DDA}"/>
-              </a:ext>
-            </a:extLst>
-          </p:cNvPr>
-          <p:cNvSpPr txBox="1"/>
-          <p:nvPr/>
-        </p:nvSpPr>
-        <p:spPr>
-          <a:xfrm>
-            <a:off x="368808" y="5910094"/>
+            <a:off x="863008" y="3002711"/>
             <a:ext cx="2549609" cy="369332"/>
           </a:xfrm>
           <a:prstGeom prst="rect">
@@ -9420,6 +9249,96 @@
           </a:prstGeom>
         </p:spPr>
       </p:pic>
+      <p:sp>
+        <p:nvSpPr>
+          <p:cNvPr id="2" name="TextBox 1">
+            <a:extLst>
+              <a:ext uri="{FF2B5EF4-FFF2-40B4-BE49-F238E27FC236}">
+                <a16:creationId xmlns:a16="http://schemas.microsoft.com/office/drawing/2014/main" id="{5937EF3A-4764-FE86-3638-2F5BE66CEFC5}"/>
+              </a:ext>
+            </a:extLst>
+          </p:cNvPr>
+          <p:cNvSpPr txBox="1"/>
+          <p:nvPr/>
+        </p:nvSpPr>
+        <p:spPr>
+          <a:xfrm>
+            <a:off x="7443923" y="2864212"/>
+            <a:ext cx="3870400" cy="646331"/>
+          </a:xfrm>
+          <a:prstGeom prst="rect">
+            <a:avLst/>
+          </a:prstGeom>
+        </p:spPr>
+        <p:txBody>
+          <a:bodyPr vert="horz" lIns="91440" tIns="45720" rIns="91440" bIns="45720" rtlCol="0">
+            <a:normAutofit/>
+          </a:bodyPr>
+          <a:lstStyle/>
+          <a:p>
+            <a:pPr indent="-228600">
+              <a:lnSpc>
+                <a:spcPct val="90000"/>
+              </a:lnSpc>
+              <a:spcAft>
+                <a:spcPts val="600"/>
+              </a:spcAft>
+              <a:buFont typeface="Arial" panose="020B0604020202020204" pitchFamily="34" charset="0"/>
+              <a:buChar char="•"/>
+            </a:pPr>
+            <a:r>
+              <a:rPr lang="en-US" sz="1700" dirty="0">
+                <a:solidFill>
+                  <a:schemeClr val="tx2">
+                    <a:lumMod val="75000"/>
+                    <a:lumOff val="25000"/>
+                  </a:schemeClr>
+                </a:solidFill>
+              </a:rPr>
+              <a:t>Solid line: SSW calculated response</a:t>
+            </a:r>
+          </a:p>
+          <a:p>
+            <a:pPr marL="285750" indent="-228600">
+              <a:lnSpc>
+                <a:spcPct val="90000"/>
+              </a:lnSpc>
+              <a:spcAft>
+                <a:spcPts val="600"/>
+              </a:spcAft>
+              <a:buFont typeface="Arial" panose="020B0604020202020204" pitchFamily="34" charset="0"/>
+              <a:buChar char="•"/>
+            </a:pPr>
+            <a:endParaRPr lang="en-US" sz="1700" dirty="0"/>
+          </a:p>
+          <a:p>
+            <a:pPr marL="285750" indent="-228600">
+              <a:lnSpc>
+                <a:spcPct val="90000"/>
+              </a:lnSpc>
+              <a:spcAft>
+                <a:spcPts val="600"/>
+              </a:spcAft>
+              <a:buFont typeface="Arial" panose="020B0604020202020204" pitchFamily="34" charset="0"/>
+              <a:buChar char="•"/>
+            </a:pPr>
+            <a:endParaRPr lang="en-US" sz="1700" dirty="0"/>
+          </a:p>
+          <a:p>
+            <a:pPr marL="285750" indent="-228600">
+              <a:lnSpc>
+                <a:spcPct val="90000"/>
+              </a:lnSpc>
+              <a:spcAft>
+                <a:spcPts val="600"/>
+              </a:spcAft>
+              <a:buFont typeface="Arial" panose="020B0604020202020204" pitchFamily="34" charset="0"/>
+              <a:buChar char="•"/>
+            </a:pPr>
+            <a:endParaRPr lang="en-US" sz="1700" dirty="0"/>
+          </a:p>
+        </p:txBody>
+      </p:sp>
     </p:spTree>
     <p:extLst>
       <p:ext uri="{BB962C8B-B14F-4D97-AF65-F5344CB8AC3E}">

</xml_diff>